<commit_message>
remove custom data, because it is baad // add a "trichter"
</commit_message>
<xml_diff>
--- a/docs/TCM-AI Projekt Präsentation.pptx
+++ b/docs/TCM-AI Projekt Präsentation.pptx
@@ -1843,11 +1843,7 @@
               </a:spcAft>
               <a:buNone/>
             </a:pPr>
-            <a:r>
-              <a:rPr lang="en-US"/>
-              <a:t>Mika</a:t>
-            </a:r>
-            <a:endParaRPr/>
+            <a:endParaRPr dirty="0"/>
           </a:p>
         </p:txBody>
       </p:sp>
@@ -1863,8 +1859,8 @@
         </p:nvSpPr>
         <p:spPr>
           <a:xfrm>
-            <a:off x="1143225" y="685800"/>
-            <a:ext cx="4572225" cy="3429000"/>
+            <a:off x="381000" y="685800"/>
+            <a:ext cx="6096000" cy="3429000"/>
           </a:xfrm>
           <a:custGeom>
             <a:avLst/>
@@ -1971,8 +1967,8 @@
         </p:nvSpPr>
         <p:spPr>
           <a:xfrm>
-            <a:off x="1143225" y="685800"/>
-            <a:ext cx="4572225" cy="3429000"/>
+            <a:off x="381000" y="685800"/>
+            <a:ext cx="6096000" cy="3429000"/>
           </a:xfrm>
           <a:custGeom>
             <a:avLst/>
@@ -2187,8 +2183,8 @@
         </p:nvSpPr>
         <p:spPr>
           <a:xfrm>
-            <a:off x="1143225" y="685800"/>
-            <a:ext cx="4572225" cy="3429000"/>
+            <a:off x="381000" y="685800"/>
+            <a:ext cx="6096000" cy="3429000"/>
           </a:xfrm>
           <a:custGeom>
             <a:avLst/>
@@ -2403,8 +2399,8 @@
         </p:nvSpPr>
         <p:spPr>
           <a:xfrm>
-            <a:off x="1143225" y="685800"/>
-            <a:ext cx="4572225" cy="3429000"/>
+            <a:off x="381000" y="685800"/>
+            <a:ext cx="6096000" cy="3429000"/>
           </a:xfrm>
           <a:custGeom>
             <a:avLst/>
@@ -2511,8 +2507,8 @@
         </p:nvSpPr>
         <p:spPr>
           <a:xfrm>
-            <a:off x="1143225" y="685800"/>
-            <a:ext cx="4572225" cy="3429000"/>
+            <a:off x="381000" y="685800"/>
+            <a:ext cx="6096000" cy="3429000"/>
           </a:xfrm>
           <a:custGeom>
             <a:avLst/>
@@ -12890,7 +12886,7 @@
               <a:buNone/>
             </a:pPr>
             <a:r>
-              <a:rPr lang="en-US" sz="1650" b="0" i="0" u="none" strike="noStrike" cap="none">
+              <a:rPr lang="en-US" sz="1650" b="0" i="0" u="none" strike="noStrike" cap="none" dirty="0" err="1">
                 <a:solidFill>
                   <a:srgbClr val="DAFFDE"/>
                 </a:solidFill>
@@ -12899,10 +12895,34 @@
                 <a:cs typeface="Urbanist"/>
                 <a:sym typeface="Urbanist"/>
               </a:rPr>
-              <a:t>Überraschend: 37-fache Grö</a:t>
+              <a:t>Überraschend</a:t>
             </a:r>
             <a:r>
-              <a:rPr lang="en-US" sz="1650">
+              <a:rPr lang="en-US" sz="1650" b="0" i="0" u="none" strike="noStrike" cap="none" dirty="0">
+                <a:solidFill>
+                  <a:srgbClr val="DAFFDE"/>
+                </a:solidFill>
+                <a:latin typeface="Urbanist"/>
+                <a:ea typeface="Urbanist"/>
+                <a:cs typeface="Urbanist"/>
+                <a:sym typeface="Urbanist"/>
+              </a:rPr>
+              <a:t>: 37-fache </a:t>
+            </a:r>
+            <a:r>
+              <a:rPr lang="en-US" sz="1650" b="0" i="0" u="none" strike="noStrike" cap="none" dirty="0" err="1">
+                <a:solidFill>
+                  <a:srgbClr val="DAFFDE"/>
+                </a:solidFill>
+                <a:latin typeface="Urbanist"/>
+                <a:ea typeface="Urbanist"/>
+                <a:cs typeface="Urbanist"/>
+                <a:sym typeface="Urbanist"/>
+              </a:rPr>
+              <a:t>Grö</a:t>
+            </a:r>
+            <a:r>
+              <a:rPr lang="en-US" sz="1650" dirty="0" err="1">
                 <a:solidFill>
                   <a:srgbClr val="DAFFDE"/>
                 </a:solidFill>
@@ -12914,7 +12934,7 @@
               <a:t>ss</a:t>
             </a:r>
             <a:r>
-              <a:rPr lang="en-US" sz="1650" b="0" i="0" u="none" strike="noStrike" cap="none">
+              <a:rPr lang="en-US" sz="1650" b="0" i="0" u="none" strike="noStrike" cap="none" dirty="0" err="1">
                 <a:solidFill>
                   <a:srgbClr val="DAFFDE"/>
                 </a:solidFill>
@@ -12923,10 +12943,10 @@
                 <a:cs typeface="Urbanist"/>
                 <a:sym typeface="Urbanist"/>
               </a:rPr>
-              <a:t>e bringt </a:t>
+              <a:t>e</a:t>
             </a:r>
             <a:r>
-              <a:rPr lang="en-US" sz="1650">
+              <a:rPr lang="en-US" sz="1650" b="0" i="0" u="none" strike="noStrike" cap="none" dirty="0">
                 <a:solidFill>
                   <a:srgbClr val="DAFFDE"/>
                 </a:solidFill>
@@ -12935,10 +12955,10 @@
                 <a:cs typeface="Urbanist"/>
                 <a:sym typeface="Urbanist"/>
               </a:rPr>
-              <a:t>kein </a:t>
+              <a:t> </a:t>
             </a:r>
             <a:r>
-              <a:rPr lang="en-US" sz="1650" b="0" i="0" u="none" strike="noStrike" cap="none">
+              <a:rPr lang="en-US" sz="1650" b="0" i="0" u="none" strike="noStrike" cap="none" dirty="0" err="1">
                 <a:solidFill>
                   <a:srgbClr val="DAFFDE"/>
                 </a:solidFill>
@@ -12947,10 +12967,70 @@
                 <a:cs typeface="Urbanist"/>
                 <a:sym typeface="Urbanist"/>
               </a:rPr>
-              <a:t>Mehrwert. </a:t>
+              <a:t>bringt</a:t>
             </a:r>
             <a:r>
-              <a:rPr lang="en-US" sz="1650" b="1">
+              <a:rPr lang="en-US" sz="1650" b="0" i="0" u="none" strike="noStrike" cap="none" dirty="0">
+                <a:solidFill>
+                  <a:srgbClr val="DAFFDE"/>
+                </a:solidFill>
+                <a:latin typeface="Urbanist"/>
+                <a:ea typeface="Urbanist"/>
+                <a:cs typeface="Urbanist"/>
+                <a:sym typeface="Urbanist"/>
+              </a:rPr>
+              <a:t> </a:t>
+            </a:r>
+            <a:r>
+              <a:rPr lang="en-US" sz="1650" dirty="0" err="1">
+                <a:solidFill>
+                  <a:srgbClr val="DAFFDE"/>
+                </a:solidFill>
+                <a:latin typeface="Urbanist"/>
+                <a:ea typeface="Urbanist"/>
+                <a:cs typeface="Urbanist"/>
+                <a:sym typeface="Urbanist"/>
+              </a:rPr>
+              <a:t>kein</a:t>
+            </a:r>
+            <a:r>
+              <a:rPr lang="en-US" sz="1650" dirty="0">
+                <a:solidFill>
+                  <a:srgbClr val="DAFFDE"/>
+                </a:solidFill>
+                <a:latin typeface="Urbanist"/>
+                <a:ea typeface="Urbanist"/>
+                <a:cs typeface="Urbanist"/>
+                <a:sym typeface="Urbanist"/>
+              </a:rPr>
+              <a:t> </a:t>
+            </a:r>
+            <a:r>
+              <a:rPr lang="en-US" sz="1650" b="0" i="0" u="none" strike="noStrike" cap="none" dirty="0" err="1">
+                <a:solidFill>
+                  <a:srgbClr val="DAFFDE"/>
+                </a:solidFill>
+                <a:latin typeface="Urbanist"/>
+                <a:ea typeface="Urbanist"/>
+                <a:cs typeface="Urbanist"/>
+                <a:sym typeface="Urbanist"/>
+              </a:rPr>
+              <a:t>Mehrwert</a:t>
+            </a:r>
+            <a:r>
+              <a:rPr lang="en-US" sz="1650" b="0" i="0" u="none" strike="noStrike" cap="none" dirty="0">
+                <a:solidFill>
+                  <a:srgbClr val="DAFFDE"/>
+                </a:solidFill>
+                <a:latin typeface="Urbanist"/>
+                <a:ea typeface="Urbanist"/>
+                <a:cs typeface="Urbanist"/>
+                <a:sym typeface="Urbanist"/>
+              </a:rPr>
+              <a:t>. </a:t>
+            </a:r>
+            <a:r>
+              <a:rPr lang="en-US" sz="1650" b="1" dirty="0">
                 <a:solidFill>
                   <a:srgbClr val="DAFFDE"/>
                 </a:solidFill>
@@ -12961,7 +13041,7 @@
               </a:rPr>
               <a:t>o3-pro (10M Parameter) cs o5.2-mini (0.3M Parameter)</a:t>
             </a:r>
-            <a:endParaRPr/>
+            <a:endParaRPr dirty="0"/>
           </a:p>
         </p:txBody>
       </p:sp>
@@ -14853,6 +14933,70 @@
           </a:p>
         </p:txBody>
       </p:sp>
+      <p:sp>
+        <p:nvSpPr>
+          <p:cNvPr id="2" name="Google Shape;117;p15">
+            <a:extLst>
+              <a:ext uri="{FF2B5EF4-FFF2-40B4-BE49-F238E27FC236}">
+                <a16:creationId xmlns:a16="http://schemas.microsoft.com/office/drawing/2014/main" id="{B8488A10-34CF-1119-1A8C-3AADC2B88372}"/>
+              </a:ext>
+            </a:extLst>
+          </p:cNvPr>
+          <p:cNvSpPr txBox="1"/>
+          <p:nvPr/>
+        </p:nvSpPr>
+        <p:spPr>
+          <a:xfrm>
+            <a:off x="8241583" y="5886300"/>
+            <a:ext cx="5736000" cy="400200"/>
+          </a:xfrm>
+          <a:prstGeom prst="rect">
+            <a:avLst/>
+          </a:prstGeom>
+          <a:noFill/>
+          <a:ln>
+            <a:noFill/>
+          </a:ln>
+        </p:spPr>
+        <p:txBody>
+          <a:bodyPr spcFirstLastPara="1" wrap="square" lIns="91425" tIns="91425" rIns="91425" bIns="91425" anchor="t" anchorCtr="0">
+            <a:spAutoFit/>
+          </a:bodyPr>
+          <a:lstStyle/>
+          <a:p>
+            <a:pPr marL="0" lvl="0" indent="0" algn="l" rtl="0">
+              <a:spcBef>
+                <a:spcPts val="0"/>
+              </a:spcBef>
+              <a:spcAft>
+                <a:spcPts val="0"/>
+              </a:spcAft>
+              <a:buNone/>
+            </a:pPr>
+            <a:r>
+              <a:rPr lang="en-US" dirty="0">
+                <a:solidFill>
+                  <a:srgbClr val="888888"/>
+                </a:solidFill>
+                <a:latin typeface="Calibri"/>
+                <a:ea typeface="Calibri"/>
+                <a:cs typeface="Calibri"/>
+                <a:sym typeface="Calibri"/>
+              </a:rPr>
+              <a:t>Bild: gemini.google.com</a:t>
+            </a:r>
+            <a:endParaRPr dirty="0">
+              <a:solidFill>
+                <a:srgbClr val="888888"/>
+              </a:solidFill>
+              <a:latin typeface="Calibri"/>
+              <a:ea typeface="Calibri"/>
+              <a:cs typeface="Calibri"/>
+              <a:sym typeface="Calibri"/>
+            </a:endParaRPr>
+          </a:p>
+        </p:txBody>
+      </p:sp>
     </p:spTree>
   </p:cSld>
   <p:clrMapOvr>
@@ -15473,7 +15617,7 @@
               <a:buNone/>
             </a:pPr>
             <a:r>
-              <a:rPr lang="en-US">
+              <a:rPr lang="en-US" dirty="0">
                 <a:solidFill>
                   <a:srgbClr val="888888"/>
                 </a:solidFill>
@@ -15484,7 +15628,7 @@
               </a:rPr>
               <a:t>Bild: gemini.google.com</a:t>
             </a:r>
-            <a:endParaRPr>
+            <a:endParaRPr dirty="0">
               <a:solidFill>
                 <a:srgbClr val="888888"/>
               </a:solidFill>
@@ -15824,7 +15968,7 @@
         <p:spPr>
           <a:xfrm>
             <a:off x="6334113" y="3659698"/>
-            <a:ext cx="5286300" cy="1320600"/>
+            <a:ext cx="5286300" cy="1421928"/>
           </a:xfrm>
           <a:prstGeom prst="rect">
             <a:avLst/>
@@ -15853,7 +15997,7 @@
               <a:buNone/>
             </a:pPr>
             <a:r>
-              <a:rPr lang="en-US" sz="1650">
+              <a:rPr lang="en-US" sz="1650" dirty="0">
                 <a:solidFill>
                   <a:srgbClr val="DAFFDE"/>
                 </a:solidFill>
@@ -15862,9 +16006,369 @@
                 <a:cs typeface="Urbanist"/>
                 <a:sym typeface="Urbanist"/>
               </a:rPr>
-              <a:t>Die Theoretischen Werte waren manchmal irreführend. trotz insgesammt weniger als 9% theorethischer verbesserung sind die Neusten Modelle Welten besser in der Praxis</a:t>
+              <a:t>Die </a:t>
             </a:r>
-            <a:endParaRPr/>
+            <a:r>
+              <a:rPr lang="en-US" sz="1650" dirty="0" err="1">
+                <a:solidFill>
+                  <a:srgbClr val="DAFFDE"/>
+                </a:solidFill>
+                <a:latin typeface="Urbanist"/>
+                <a:ea typeface="Urbanist"/>
+                <a:cs typeface="Urbanist"/>
+                <a:sym typeface="Urbanist"/>
+              </a:rPr>
+              <a:t>Theoretischen</a:t>
+            </a:r>
+            <a:r>
+              <a:rPr lang="en-US" sz="1650" dirty="0">
+                <a:solidFill>
+                  <a:srgbClr val="DAFFDE"/>
+                </a:solidFill>
+                <a:latin typeface="Urbanist"/>
+                <a:ea typeface="Urbanist"/>
+                <a:cs typeface="Urbanist"/>
+                <a:sym typeface="Urbanist"/>
+              </a:rPr>
+              <a:t> </a:t>
+            </a:r>
+            <a:r>
+              <a:rPr lang="en-US" sz="1650" dirty="0" err="1">
+                <a:solidFill>
+                  <a:srgbClr val="DAFFDE"/>
+                </a:solidFill>
+                <a:latin typeface="Urbanist"/>
+                <a:ea typeface="Urbanist"/>
+                <a:cs typeface="Urbanist"/>
+                <a:sym typeface="Urbanist"/>
+              </a:rPr>
+              <a:t>Werte</a:t>
+            </a:r>
+            <a:r>
+              <a:rPr lang="en-US" sz="1650" dirty="0">
+                <a:solidFill>
+                  <a:srgbClr val="DAFFDE"/>
+                </a:solidFill>
+                <a:latin typeface="Urbanist"/>
+                <a:ea typeface="Urbanist"/>
+                <a:cs typeface="Urbanist"/>
+                <a:sym typeface="Urbanist"/>
+              </a:rPr>
+              <a:t> </a:t>
+            </a:r>
+            <a:r>
+              <a:rPr lang="en-US" sz="1650" dirty="0" err="1">
+                <a:solidFill>
+                  <a:srgbClr val="DAFFDE"/>
+                </a:solidFill>
+                <a:latin typeface="Urbanist"/>
+                <a:ea typeface="Urbanist"/>
+                <a:cs typeface="Urbanist"/>
+                <a:sym typeface="Urbanist"/>
+              </a:rPr>
+              <a:t>waren</a:t>
+            </a:r>
+            <a:r>
+              <a:rPr lang="en-US" sz="1650" dirty="0">
+                <a:solidFill>
+                  <a:srgbClr val="DAFFDE"/>
+                </a:solidFill>
+                <a:latin typeface="Urbanist"/>
+                <a:ea typeface="Urbanist"/>
+                <a:cs typeface="Urbanist"/>
+                <a:sym typeface="Urbanist"/>
+              </a:rPr>
+              <a:t> </a:t>
+            </a:r>
+            <a:r>
+              <a:rPr lang="en-US" sz="1650" dirty="0" err="1">
+                <a:solidFill>
+                  <a:srgbClr val="DAFFDE"/>
+                </a:solidFill>
+                <a:latin typeface="Urbanist"/>
+                <a:ea typeface="Urbanist"/>
+                <a:cs typeface="Urbanist"/>
+                <a:sym typeface="Urbanist"/>
+              </a:rPr>
+              <a:t>manchmal</a:t>
+            </a:r>
+            <a:r>
+              <a:rPr lang="en-US" sz="1650" dirty="0">
+                <a:solidFill>
+                  <a:srgbClr val="DAFFDE"/>
+                </a:solidFill>
+                <a:latin typeface="Urbanist"/>
+                <a:ea typeface="Urbanist"/>
+                <a:cs typeface="Urbanist"/>
+                <a:sym typeface="Urbanist"/>
+              </a:rPr>
+              <a:t> </a:t>
+            </a:r>
+            <a:r>
+              <a:rPr lang="en-US" sz="1650" dirty="0" err="1">
+                <a:solidFill>
+                  <a:srgbClr val="DAFFDE"/>
+                </a:solidFill>
+                <a:latin typeface="Urbanist"/>
+                <a:ea typeface="Urbanist"/>
+                <a:cs typeface="Urbanist"/>
+                <a:sym typeface="Urbanist"/>
+              </a:rPr>
+              <a:t>irreführend</a:t>
+            </a:r>
+            <a:r>
+              <a:rPr lang="en-US" sz="1650" dirty="0">
+                <a:solidFill>
+                  <a:srgbClr val="DAFFDE"/>
+                </a:solidFill>
+                <a:latin typeface="Urbanist"/>
+                <a:ea typeface="Urbanist"/>
+                <a:cs typeface="Urbanist"/>
+                <a:sym typeface="Urbanist"/>
+              </a:rPr>
+              <a:t>. </a:t>
+            </a:r>
+            <a:r>
+              <a:rPr lang="en-US" sz="1650" dirty="0" err="1">
+                <a:solidFill>
+                  <a:srgbClr val="DAFFDE"/>
+                </a:solidFill>
+                <a:latin typeface="Urbanist"/>
+                <a:ea typeface="Urbanist"/>
+                <a:cs typeface="Urbanist"/>
+                <a:sym typeface="Urbanist"/>
+              </a:rPr>
+              <a:t>trotz</a:t>
+            </a:r>
+            <a:r>
+              <a:rPr lang="en-US" sz="1650" dirty="0">
+                <a:solidFill>
+                  <a:srgbClr val="DAFFDE"/>
+                </a:solidFill>
+                <a:latin typeface="Urbanist"/>
+                <a:ea typeface="Urbanist"/>
+                <a:cs typeface="Urbanist"/>
+                <a:sym typeface="Urbanist"/>
+              </a:rPr>
+              <a:t> </a:t>
+            </a:r>
+            <a:r>
+              <a:rPr lang="en-US" sz="1650" dirty="0" err="1">
+                <a:solidFill>
+                  <a:srgbClr val="DAFFDE"/>
+                </a:solidFill>
+                <a:latin typeface="Urbanist"/>
+                <a:ea typeface="Urbanist"/>
+                <a:cs typeface="Urbanist"/>
+                <a:sym typeface="Urbanist"/>
+              </a:rPr>
+              <a:t>insgesammt</a:t>
+            </a:r>
+            <a:r>
+              <a:rPr lang="en-US" sz="1650" dirty="0">
+                <a:solidFill>
+                  <a:srgbClr val="DAFFDE"/>
+                </a:solidFill>
+                <a:latin typeface="Urbanist"/>
+                <a:ea typeface="Urbanist"/>
+                <a:cs typeface="Urbanist"/>
+                <a:sym typeface="Urbanist"/>
+              </a:rPr>
+              <a:t> </a:t>
+            </a:r>
+            <a:r>
+              <a:rPr lang="en-US" sz="1650" dirty="0" err="1">
+                <a:solidFill>
+                  <a:srgbClr val="DAFFDE"/>
+                </a:solidFill>
+                <a:latin typeface="Urbanist"/>
+                <a:ea typeface="Urbanist"/>
+                <a:cs typeface="Urbanist"/>
+                <a:sym typeface="Urbanist"/>
+              </a:rPr>
+              <a:t>weniger</a:t>
+            </a:r>
+            <a:r>
+              <a:rPr lang="en-US" sz="1650" dirty="0">
+                <a:solidFill>
+                  <a:srgbClr val="DAFFDE"/>
+                </a:solidFill>
+                <a:latin typeface="Urbanist"/>
+                <a:ea typeface="Urbanist"/>
+                <a:cs typeface="Urbanist"/>
+                <a:sym typeface="Urbanist"/>
+              </a:rPr>
+              <a:t> </a:t>
+            </a:r>
+            <a:r>
+              <a:rPr lang="en-US" sz="1650" dirty="0" err="1">
+                <a:solidFill>
+                  <a:srgbClr val="DAFFDE"/>
+                </a:solidFill>
+                <a:latin typeface="Urbanist"/>
+                <a:ea typeface="Urbanist"/>
+                <a:cs typeface="Urbanist"/>
+                <a:sym typeface="Urbanist"/>
+              </a:rPr>
+              <a:t>als</a:t>
+            </a:r>
+            <a:r>
+              <a:rPr lang="en-US" sz="1650" dirty="0">
+                <a:solidFill>
+                  <a:srgbClr val="DAFFDE"/>
+                </a:solidFill>
+                <a:latin typeface="Urbanist"/>
+                <a:ea typeface="Urbanist"/>
+                <a:cs typeface="Urbanist"/>
+                <a:sym typeface="Urbanist"/>
+              </a:rPr>
+              <a:t> 9% </a:t>
+            </a:r>
+            <a:r>
+              <a:rPr lang="en-US" sz="1650" dirty="0" err="1">
+                <a:solidFill>
+                  <a:srgbClr val="DAFFDE"/>
+                </a:solidFill>
+                <a:latin typeface="Urbanist"/>
+                <a:ea typeface="Urbanist"/>
+                <a:cs typeface="Urbanist"/>
+                <a:sym typeface="Urbanist"/>
+              </a:rPr>
+              <a:t>theorethischer</a:t>
+            </a:r>
+            <a:r>
+              <a:rPr lang="en-US" sz="1650" dirty="0">
+                <a:solidFill>
+                  <a:srgbClr val="DAFFDE"/>
+                </a:solidFill>
+                <a:latin typeface="Urbanist"/>
+                <a:ea typeface="Urbanist"/>
+                <a:cs typeface="Urbanist"/>
+                <a:sym typeface="Urbanist"/>
+              </a:rPr>
+              <a:t> </a:t>
+            </a:r>
+            <a:r>
+              <a:rPr lang="en-US" sz="1650" dirty="0" err="1">
+                <a:solidFill>
+                  <a:srgbClr val="DAFFDE"/>
+                </a:solidFill>
+                <a:latin typeface="Urbanist"/>
+                <a:ea typeface="Urbanist"/>
+                <a:cs typeface="Urbanist"/>
+                <a:sym typeface="Urbanist"/>
+              </a:rPr>
+              <a:t>Verbesserung</a:t>
+            </a:r>
+            <a:r>
+              <a:rPr lang="en-US" sz="1650" dirty="0">
+                <a:solidFill>
+                  <a:srgbClr val="DAFFDE"/>
+                </a:solidFill>
+                <a:latin typeface="Urbanist"/>
+                <a:ea typeface="Urbanist"/>
+                <a:cs typeface="Urbanist"/>
+                <a:sym typeface="Urbanist"/>
+              </a:rPr>
+              <a:t> </a:t>
+            </a:r>
+            <a:r>
+              <a:rPr lang="en-US" sz="1650" dirty="0" err="1">
+                <a:solidFill>
+                  <a:srgbClr val="DAFFDE"/>
+                </a:solidFill>
+                <a:latin typeface="Urbanist"/>
+                <a:ea typeface="Urbanist"/>
+                <a:cs typeface="Urbanist"/>
+                <a:sym typeface="Urbanist"/>
+              </a:rPr>
+              <a:t>sind</a:t>
+            </a:r>
+            <a:r>
+              <a:rPr lang="en-US" sz="1650" dirty="0">
+                <a:solidFill>
+                  <a:srgbClr val="DAFFDE"/>
+                </a:solidFill>
+                <a:latin typeface="Urbanist"/>
+                <a:ea typeface="Urbanist"/>
+                <a:cs typeface="Urbanist"/>
+                <a:sym typeface="Urbanist"/>
+              </a:rPr>
+              <a:t> die </a:t>
+            </a:r>
+            <a:r>
+              <a:rPr lang="en-US" sz="1650" dirty="0" err="1">
+                <a:solidFill>
+                  <a:srgbClr val="DAFFDE"/>
+                </a:solidFill>
+                <a:latin typeface="Urbanist"/>
+                <a:ea typeface="Urbanist"/>
+                <a:cs typeface="Urbanist"/>
+                <a:sym typeface="Urbanist"/>
+              </a:rPr>
+              <a:t>neusten</a:t>
+            </a:r>
+            <a:r>
+              <a:rPr lang="en-US" sz="1650" dirty="0">
+                <a:solidFill>
+                  <a:srgbClr val="DAFFDE"/>
+                </a:solidFill>
+                <a:latin typeface="Urbanist"/>
+                <a:ea typeface="Urbanist"/>
+                <a:cs typeface="Urbanist"/>
+                <a:sym typeface="Urbanist"/>
+              </a:rPr>
+              <a:t> Modelle </a:t>
+            </a:r>
+            <a:r>
+              <a:rPr lang="en-US" sz="1650" dirty="0" err="1">
+                <a:solidFill>
+                  <a:srgbClr val="DAFFDE"/>
+                </a:solidFill>
+                <a:latin typeface="Urbanist"/>
+                <a:ea typeface="Urbanist"/>
+                <a:cs typeface="Urbanist"/>
+                <a:sym typeface="Urbanist"/>
+              </a:rPr>
+              <a:t>Welten</a:t>
+            </a:r>
+            <a:r>
+              <a:rPr lang="en-US" sz="1650" dirty="0">
+                <a:solidFill>
+                  <a:srgbClr val="DAFFDE"/>
+                </a:solidFill>
+                <a:latin typeface="Urbanist"/>
+                <a:ea typeface="Urbanist"/>
+                <a:cs typeface="Urbanist"/>
+                <a:sym typeface="Urbanist"/>
+              </a:rPr>
+              <a:t> </a:t>
+            </a:r>
+            <a:r>
+              <a:rPr lang="en-US" sz="1650" dirty="0" err="1">
+                <a:solidFill>
+                  <a:srgbClr val="DAFFDE"/>
+                </a:solidFill>
+                <a:latin typeface="Urbanist"/>
+                <a:ea typeface="Urbanist"/>
+                <a:cs typeface="Urbanist"/>
+                <a:sym typeface="Urbanist"/>
+              </a:rPr>
+              <a:t>besser</a:t>
+            </a:r>
+            <a:r>
+              <a:rPr lang="en-US" sz="1650" dirty="0">
+                <a:solidFill>
+                  <a:srgbClr val="DAFFDE"/>
+                </a:solidFill>
+                <a:latin typeface="Urbanist"/>
+                <a:ea typeface="Urbanist"/>
+                <a:cs typeface="Urbanist"/>
+                <a:sym typeface="Urbanist"/>
+              </a:rPr>
+              <a:t> in der Praxis</a:t>
+            </a:r>
+            <a:endParaRPr dirty="0"/>
           </a:p>
         </p:txBody>
       </p:sp>
@@ -16644,7 +17148,7 @@
               <a:buNone/>
             </a:pPr>
             <a:r>
-              <a:rPr lang="en-US" sz="1650" b="0" i="0" u="none" strike="noStrike" cap="none">
+              <a:rPr lang="en-US" sz="1650" b="0" i="0" u="none" strike="noStrike" cap="none" dirty="0">
                 <a:solidFill>
                   <a:srgbClr val="DAFFDE"/>
                 </a:solidFill>
@@ -16653,10 +17157,10 @@
                 <a:cs typeface="Urbanist"/>
                 <a:sym typeface="Urbanist"/>
               </a:rPr>
-              <a:t>Die wichtigste Lektion: </a:t>
+              <a:t>Die </a:t>
             </a:r>
             <a:r>
-              <a:rPr lang="en-US" sz="1650" b="1" i="0" u="none" strike="noStrike" cap="none">
+              <a:rPr lang="en-US" sz="1650" b="0" i="0" u="none" strike="noStrike" cap="none" dirty="0" err="1">
                 <a:solidFill>
                   <a:srgbClr val="DAFFDE"/>
                 </a:solidFill>
@@ -16665,9 +17169,141 @@
                 <a:cs typeface="Urbanist"/>
                 <a:sym typeface="Urbanist"/>
               </a:rPr>
-              <a:t>Datenqualität und -quantität schlagen oft Modell-Komplexität.</a:t>
+              <a:t>wichtigste</a:t>
             </a:r>
-            <a:endParaRPr/>
+            <a:r>
+              <a:rPr lang="en-US" sz="1650" b="0" i="0" u="none" strike="noStrike" cap="none" dirty="0">
+                <a:solidFill>
+                  <a:srgbClr val="DAFFDE"/>
+                </a:solidFill>
+                <a:latin typeface="Urbanist"/>
+                <a:ea typeface="Urbanist"/>
+                <a:cs typeface="Urbanist"/>
+                <a:sym typeface="Urbanist"/>
+              </a:rPr>
+              <a:t> </a:t>
+            </a:r>
+            <a:r>
+              <a:rPr lang="en-US" sz="1650" b="0" i="0" u="none" strike="noStrike" cap="none" dirty="0" err="1">
+                <a:solidFill>
+                  <a:srgbClr val="DAFFDE"/>
+                </a:solidFill>
+                <a:latin typeface="Urbanist"/>
+                <a:ea typeface="Urbanist"/>
+                <a:cs typeface="Urbanist"/>
+                <a:sym typeface="Urbanist"/>
+              </a:rPr>
+              <a:t>Lektion</a:t>
+            </a:r>
+            <a:r>
+              <a:rPr lang="en-US" sz="1650" b="0" i="0" u="none" strike="noStrike" cap="none" dirty="0">
+                <a:solidFill>
+                  <a:srgbClr val="DAFFDE"/>
+                </a:solidFill>
+                <a:latin typeface="Urbanist"/>
+                <a:ea typeface="Urbanist"/>
+                <a:cs typeface="Urbanist"/>
+                <a:sym typeface="Urbanist"/>
+              </a:rPr>
+              <a:t>: </a:t>
+            </a:r>
+            <a:r>
+              <a:rPr lang="en-US" sz="1650" b="1" i="0" u="none" strike="noStrike" cap="none" dirty="0" err="1">
+                <a:solidFill>
+                  <a:srgbClr val="DAFFDE"/>
+                </a:solidFill>
+                <a:latin typeface="Urbanist"/>
+                <a:ea typeface="Urbanist"/>
+                <a:cs typeface="Urbanist"/>
+                <a:sym typeface="Urbanist"/>
+              </a:rPr>
+              <a:t>Datenqualität</a:t>
+            </a:r>
+            <a:r>
+              <a:rPr lang="en-US" sz="1650" b="1" i="0" u="none" strike="noStrike" cap="none" dirty="0">
+                <a:solidFill>
+                  <a:srgbClr val="DAFFDE"/>
+                </a:solidFill>
+                <a:latin typeface="Urbanist"/>
+                <a:ea typeface="Urbanist"/>
+                <a:cs typeface="Urbanist"/>
+                <a:sym typeface="Urbanist"/>
+              </a:rPr>
+              <a:t> und -</a:t>
+            </a:r>
+            <a:r>
+              <a:rPr lang="en-US" sz="1650" b="1" i="0" u="none" strike="noStrike" cap="none" dirty="0" err="1">
+                <a:solidFill>
+                  <a:srgbClr val="DAFFDE"/>
+                </a:solidFill>
+                <a:latin typeface="Urbanist"/>
+                <a:ea typeface="Urbanist"/>
+                <a:cs typeface="Urbanist"/>
+                <a:sym typeface="Urbanist"/>
+              </a:rPr>
+              <a:t>quantität</a:t>
+            </a:r>
+            <a:r>
+              <a:rPr lang="en-US" sz="1650" b="1" i="0" u="none" strike="noStrike" cap="none" dirty="0">
+                <a:solidFill>
+                  <a:srgbClr val="DAFFDE"/>
+                </a:solidFill>
+                <a:latin typeface="Urbanist"/>
+                <a:ea typeface="Urbanist"/>
+                <a:cs typeface="Urbanist"/>
+                <a:sym typeface="Urbanist"/>
+              </a:rPr>
+              <a:t> </a:t>
+            </a:r>
+            <a:r>
+              <a:rPr lang="en-US" sz="1650" b="1" i="0" u="none" strike="noStrike" cap="none" dirty="0" err="1">
+                <a:solidFill>
+                  <a:srgbClr val="DAFFDE"/>
+                </a:solidFill>
+                <a:latin typeface="Urbanist"/>
+                <a:ea typeface="Urbanist"/>
+                <a:cs typeface="Urbanist"/>
+                <a:sym typeface="Urbanist"/>
+              </a:rPr>
+              <a:t>schlagen</a:t>
+            </a:r>
+            <a:r>
+              <a:rPr lang="en-US" sz="1650" b="1" i="0" u="none" strike="noStrike" cap="none" dirty="0">
+                <a:solidFill>
+                  <a:srgbClr val="DAFFDE"/>
+                </a:solidFill>
+                <a:latin typeface="Urbanist"/>
+                <a:ea typeface="Urbanist"/>
+                <a:cs typeface="Urbanist"/>
+                <a:sym typeface="Urbanist"/>
+              </a:rPr>
+              <a:t> oft Modell-</a:t>
+            </a:r>
+            <a:r>
+              <a:rPr lang="en-US" sz="1650" b="1" i="0" u="none" strike="noStrike" cap="none" dirty="0" err="1">
+                <a:solidFill>
+                  <a:srgbClr val="DAFFDE"/>
+                </a:solidFill>
+                <a:latin typeface="Urbanist"/>
+                <a:ea typeface="Urbanist"/>
+                <a:cs typeface="Urbanist"/>
+                <a:sym typeface="Urbanist"/>
+              </a:rPr>
+              <a:t>Komplexität</a:t>
+            </a:r>
+            <a:r>
+              <a:rPr lang="en-US" sz="1650" b="1" i="0" u="none" strike="noStrike" cap="none" dirty="0">
+                <a:solidFill>
+                  <a:srgbClr val="DAFFDE"/>
+                </a:solidFill>
+                <a:latin typeface="Urbanist"/>
+                <a:ea typeface="Urbanist"/>
+                <a:cs typeface="Urbanist"/>
+                <a:sym typeface="Urbanist"/>
+              </a:rPr>
+              <a:t>.</a:t>
+            </a:r>
+            <a:endParaRPr dirty="0"/>
           </a:p>
         </p:txBody>
       </p:sp>
@@ -17276,7 +17912,7 @@
         </p:nvSpPr>
         <p:spPr>
           <a:xfrm>
-            <a:off x="571500" y="4726185"/>
+            <a:off x="594237" y="5100146"/>
             <a:ext cx="5286375" cy="293340"/>
           </a:xfrm>
           <a:prstGeom prst="rect">
@@ -17306,7 +17942,7 @@
               <a:buNone/>
             </a:pPr>
             <a:r>
-              <a:rPr lang="en-US" sz="1650" b="0" i="0" u="none" strike="noStrike" cap="none">
+              <a:rPr lang="en-US" sz="1650" b="0" i="0" u="none" strike="noStrike" cap="none" dirty="0" err="1">
                 <a:solidFill>
                   <a:srgbClr val="DAFFDE"/>
                 </a:solidFill>
@@ -17315,10 +17951,22 @@
                 <a:cs typeface="Urbanist"/>
                 <a:sym typeface="Urbanist"/>
               </a:rPr>
-              <a:t>Ergebnis: Sprung auf </a:t>
+              <a:t>Ergebnis</a:t>
             </a:r>
             <a:r>
-              <a:rPr lang="en-US" sz="1650" b="1" i="0" u="none" strike="noStrike" cap="none">
+              <a:rPr lang="en-US" sz="1650" b="0" i="0" u="none" strike="noStrike" cap="none" dirty="0">
+                <a:solidFill>
+                  <a:srgbClr val="DAFFDE"/>
+                </a:solidFill>
+                <a:latin typeface="Urbanist"/>
+                <a:ea typeface="Urbanist"/>
+                <a:cs typeface="Urbanist"/>
+                <a:sym typeface="Urbanist"/>
+              </a:rPr>
+              <a:t>: Sprung auf </a:t>
+            </a:r>
+            <a:r>
+              <a:rPr lang="en-US" sz="1650" b="1" i="0" u="none" strike="noStrike" cap="none" dirty="0">
                 <a:solidFill>
                   <a:srgbClr val="DAFFDE"/>
                 </a:solidFill>
@@ -17330,7 +17978,7 @@
               <a:t>98,2%</a:t>
             </a:r>
             <a:r>
-              <a:rPr lang="en-US" sz="1650" b="0" i="0" u="none" strike="noStrike" cap="none">
+              <a:rPr lang="en-US" sz="1650" b="0" i="0" u="none" strike="noStrike" cap="none" dirty="0">
                 <a:solidFill>
                   <a:srgbClr val="DAFFDE"/>
                 </a:solidFill>
@@ -17341,7 +17989,7 @@
               </a:rPr>
               <a:t> Accuracy.</a:t>
             </a:r>
-            <a:endParaRPr/>
+            <a:endParaRPr dirty="0"/>
           </a:p>
         </p:txBody>
       </p:sp>

</xml_diff>